<commit_message>
more or less stable
</commit_message>
<xml_diff>
--- a/OrgStructure.pptx
+++ b/OrgStructure.pptx
@@ -913,6 +913,256 @@
                 </a:solidFill>
               </a:rPr>
               <a:t>Руководитель: Глазунов Всеволод Игоревич</a:t>
+            </a:r>
+            <a:endParaRPr lang="en-US" sz="1200" dirty="0"/>
+          </a:p>
+        </p:txBody>
+      </p:sp>
+      <p:sp>
+        <p:nvSpPr>
+          <p:cNvPr id="3" name="Text 1"/>
+          <p:cNvSpPr/>
+          <p:nvPr/>
+        </p:nvSpPr>
+        <p:spPr>
+          <a:xfrm>
+            <a:off x="457200" y="1097280"/>
+            <a:ext cx="8229600" cy="457200"/>
+          </a:xfrm>
+          <a:prstGeom prst="rect">
+            <a:avLst/>
+          </a:prstGeom>
+          <a:noFill/>
+          <a:ln/>
+        </p:spPr>
+        <p:txBody>
+          <a:bodyPr wrap="square" rtlCol="0" anchor="ctr"/>
+          <a:lstStyle/>
+          <a:p>
+            <a:pPr indent="0" marL="0">
+              <a:buNone/>
+            </a:pPr>
+            <a:r>
+              <a:rPr lang="en-US" sz="1200" dirty="0">
+                <a:solidFill>
+                  <a:srgbClr val="000000"/>
+                </a:solidFill>
+              </a:rPr>
+              <a:t>Маркетинговая лаборатория (7 чел.)</a:t>
+            </a:r>
+            <a:endParaRPr lang="en-US" sz="1200" dirty="0"/>
+          </a:p>
+          <a:p>
+            <a:pPr indent="0" marL="0">
+              <a:buNone/>
+            </a:pPr>
+            <a:r>
+              <a:rPr lang="en-US" sz="1200" dirty="0">
+                <a:solidFill>
+                  <a:srgbClr val="000000"/>
+                </a:solidFill>
+              </a:rPr>
+              <a:t>Руководитель: Григорьева Наталья Андреевна</a:t>
+            </a:r>
+            <a:endParaRPr lang="en-US" sz="1200" dirty="0"/>
+          </a:p>
+        </p:txBody>
+      </p:sp>
+      <p:sp>
+        <p:nvSpPr>
+          <p:cNvPr id="4" name="Text 2"/>
+          <p:cNvSpPr/>
+          <p:nvPr/>
+        </p:nvSpPr>
+        <p:spPr>
+          <a:xfrm>
+            <a:off x="457200" y="1737360"/>
+            <a:ext cx="8229600" cy="457200"/>
+          </a:xfrm>
+          <a:prstGeom prst="rect">
+            <a:avLst/>
+          </a:prstGeom>
+          <a:noFill/>
+          <a:ln/>
+        </p:spPr>
+        <p:txBody>
+          <a:bodyPr wrap="square" rtlCol="0" anchor="ctr"/>
+          <a:lstStyle/>
+          <a:p>
+            <a:pPr indent="0" marL="0">
+              <a:buNone/>
+            </a:pPr>
+            <a:r>
+              <a:rPr lang="en-US" sz="1200" dirty="0">
+                <a:solidFill>
+                  <a:srgbClr val="000000"/>
+                </a:solidFill>
+              </a:rPr>
+              <a:t>Отдел аналитики (7 чел.)</a:t>
+            </a:r>
+            <a:endParaRPr lang="en-US" sz="1200" dirty="0"/>
+          </a:p>
+          <a:p>
+            <a:pPr indent="0" marL="0">
+              <a:buNone/>
+            </a:pPr>
+            <a:r>
+              <a:rPr lang="en-US" sz="1200" dirty="0">
+                <a:solidFill>
+                  <a:srgbClr val="000000"/>
+                </a:solidFill>
+              </a:rPr>
+              <a:t>Руководитель: Ильдарова София Игоревна</a:t>
+            </a:r>
+            <a:endParaRPr lang="en-US" sz="1200" dirty="0"/>
+          </a:p>
+        </p:txBody>
+      </p:sp>
+      <p:sp>
+        <p:nvSpPr>
+          <p:cNvPr id="5" name="Text 3"/>
+          <p:cNvSpPr/>
+          <p:nvPr/>
+        </p:nvSpPr>
+        <p:spPr>
+          <a:xfrm>
+            <a:off x="457200" y="2377440"/>
+            <a:ext cx="8229600" cy="457200"/>
+          </a:xfrm>
+          <a:prstGeom prst="rect">
+            <a:avLst/>
+          </a:prstGeom>
+          <a:noFill/>
+          <a:ln/>
+        </p:spPr>
+        <p:txBody>
+          <a:bodyPr wrap="square" rtlCol="0" anchor="ctr"/>
+          <a:lstStyle/>
+          <a:p>
+            <a:pPr indent="0" marL="0">
+              <a:buNone/>
+            </a:pPr>
+            <a:r>
+              <a:rPr lang="en-US" sz="1200" dirty="0">
+                <a:solidFill>
+                  <a:srgbClr val="000000"/>
+                </a:solidFill>
+              </a:rPr>
+              <a:t>Отдел аудита и стандартов (0 чел.)</a:t>
+            </a:r>
+            <a:endParaRPr lang="en-US" sz="1200" dirty="0"/>
+          </a:p>
+          <a:p>
+            <a:pPr indent="0" marL="0">
+              <a:buNone/>
+            </a:pPr>
+            <a:r>
+              <a:rPr lang="en-US" sz="1200" dirty="0">
+                <a:solidFill>
+                  <a:srgbClr val="000000"/>
+                </a:solidFill>
+              </a:rPr>
+              <a:t>Руководитель: Глазунов Всеволод Игоревич</a:t>
+            </a:r>
+            <a:endParaRPr lang="en-US" sz="1200" dirty="0"/>
+          </a:p>
+        </p:txBody>
+      </p:sp>
+      <p:sp>
+        <p:nvSpPr>
+          <p:cNvPr id="6" name="Text 4"/>
+          <p:cNvSpPr/>
+          <p:nvPr/>
+        </p:nvSpPr>
+        <p:spPr>
+          <a:xfrm>
+            <a:off x="457200" y="3017520"/>
+            <a:ext cx="8229600" cy="457200"/>
+          </a:xfrm>
+          <a:prstGeom prst="rect">
+            <a:avLst/>
+          </a:prstGeom>
+          <a:noFill/>
+          <a:ln/>
+        </p:spPr>
+        <p:txBody>
+          <a:bodyPr wrap="square" rtlCol="0" anchor="ctr"/>
+          <a:lstStyle/>
+          <a:p>
+            <a:pPr indent="0" marL="0">
+              <a:buNone/>
+            </a:pPr>
+            <a:r>
+              <a:rPr lang="en-US" sz="1200" dirty="0">
+                <a:solidFill>
+                  <a:srgbClr val="000000"/>
+                </a:solidFill>
+              </a:rPr>
+              <a:t>Отдел маркетинговой информации и обучения продукту (2 чел.)</a:t>
+            </a:r>
+            <a:endParaRPr lang="en-US" sz="1200" dirty="0"/>
+          </a:p>
+          <a:p>
+            <a:pPr indent="0" marL="0">
+              <a:buNone/>
+            </a:pPr>
+            <a:r>
+              <a:rPr lang="en-US" sz="1200" dirty="0">
+                <a:solidFill>
+                  <a:srgbClr val="000000"/>
+                </a:solidFill>
+              </a:rPr>
+              <a:t>Руководитель: Слободенюк Анна Юрьевна</a:t>
+            </a:r>
+            <a:endParaRPr lang="en-US" sz="1200" dirty="0"/>
+          </a:p>
+        </p:txBody>
+      </p:sp>
+      <p:sp>
+        <p:nvSpPr>
+          <p:cNvPr id="7" name="Text 5"/>
+          <p:cNvSpPr/>
+          <p:nvPr/>
+        </p:nvSpPr>
+        <p:spPr>
+          <a:xfrm>
+            <a:off x="457200" y="3657600"/>
+            <a:ext cx="8229600" cy="457200"/>
+          </a:xfrm>
+          <a:prstGeom prst="rect">
+            <a:avLst/>
+          </a:prstGeom>
+          <a:noFill/>
+          <a:ln/>
+        </p:spPr>
+        <p:txBody>
+          <a:bodyPr wrap="square" rtlCol="0" anchor="ctr"/>
+          <a:lstStyle/>
+          <a:p>
+            <a:pPr indent="0" marL="0">
+              <a:buNone/>
+            </a:pPr>
+            <a:r>
+              <a:rPr lang="en-US" sz="1200" dirty="0">
+                <a:solidFill>
+                  <a:srgbClr val="000000"/>
+                </a:solidFill>
+              </a:rPr>
+              <a:t>Служба цифрового маркетинга (2 чел.)</a:t>
+            </a:r>
+            <a:endParaRPr lang="en-US" sz="1200" dirty="0"/>
+          </a:p>
+          <a:p>
+            <a:pPr indent="0" marL="0">
+              <a:buNone/>
+            </a:pPr>
+            <a:r>
+              <a:rPr lang="en-US" sz="1200" dirty="0">
+                <a:solidFill>
+                  <a:srgbClr val="000000"/>
+                </a:solidFill>
+              </a:rPr>
+              <a:t>Руководитель: -</a:t>
             </a:r>
             <a:endParaRPr lang="en-US" sz="1200" dirty="0"/>
           </a:p>

</xml_diff>

<commit_message>
fixed vibe coded version
</commit_message>
<xml_diff>
--- a/OrgStructure.pptx
+++ b/OrgStructure.pptx
@@ -936,7 +936,7 @@
                   <a:srgbClr val="000000"/>
                 </a:solidFill>
               </a:rPr>
-              <a:t>Дирекция по информационным технологиям</a:t>
+              <a:t>Дирекция по инвестициям</a:t>
             </a:r>
             <a:endParaRPr lang="en-US" sz="1200" dirty="0"/>
           </a:p>
@@ -950,7 +950,7 @@
                   <a:srgbClr val="000000"/>
                 </a:solidFill>
               </a:rPr>
-              <a:t>Руководитель: Быковский Роман Вадимович</a:t>
+              <a:t>Руководитель: Болилая Александра Сергеевна</a:t>
             </a:r>
             <a:endParaRPr lang="en-US" sz="1200" dirty="0"/>
           </a:p>
@@ -988,7 +988,7 @@
                   <a:srgbClr val="000000"/>
                 </a:solidFill>
               </a:rPr>
-              <a:t>Отдел аналитики</a:t>
+              <a:t>Отдел ценных бумаг и аналитики</a:t>
             </a:r>
             <a:endParaRPr lang="en-US" sz="1200" dirty="0"/>
           </a:p>
@@ -1002,735 +1002,7 @@
                   <a:srgbClr val="000000"/>
                 </a:solidFill>
               </a:rPr>
-              <a:t>Руководитель: Шапошников Алексей Викторович</a:t>
-            </a:r>
-            <a:endParaRPr lang="en-US" sz="1200" dirty="0"/>
-          </a:p>
-        </p:txBody>
-      </p:sp>
-      <p:sp>
-        <p:nvSpPr>
-          <p:cNvPr id="5" name="Text 3"/>
-          <p:cNvSpPr/>
-          <p:nvPr/>
-        </p:nvSpPr>
-        <p:spPr>
-          <a:xfrm>
-            <a:off x="3931920" y="2560320"/>
-            <a:ext cx="3200400" cy="640080"/>
-          </a:xfrm>
-          <a:prstGeom prst="rect">
-            <a:avLst/>
-          </a:prstGeom>
-          <a:solidFill>
-            <a:srgbClr val="BFDFFF"/>
-          </a:solidFill>
-          <a:ln/>
-        </p:spPr>
-        <p:txBody>
-          <a:bodyPr wrap="square" rtlCol="0" anchor="ctr"/>
-          <a:lstStyle/>
-          <a:p>
-            <a:pPr algn="ctr" indent="0" marL="0">
-              <a:buNone/>
-            </a:pPr>
-            <a:r>
-              <a:rPr lang="en-US" sz="1200" b="1" dirty="0">
-                <a:solidFill>
-                  <a:srgbClr val="000000"/>
-                </a:solidFill>
-              </a:rPr>
-              <a:t>Отдел информационных технологий в г. Москве</a:t>
-            </a:r>
-            <a:endParaRPr lang="en-US" sz="1200" dirty="0"/>
-          </a:p>
-          <a:p>
-            <a:pPr algn="ctr" indent="0" marL="0">
-              <a:buNone/>
-            </a:pPr>
-            <a:r>
-              <a:rPr lang="en-US" sz="1200" b="1" dirty="0">
-                <a:solidFill>
-                  <a:srgbClr val="000000"/>
-                </a:solidFill>
-              </a:rPr>
-              <a:t>Руководитель: Толкаев Евгений Юрьевич</a:t>
-            </a:r>
-            <a:endParaRPr lang="en-US" sz="1200" dirty="0"/>
-          </a:p>
-        </p:txBody>
-      </p:sp>
-      <p:sp>
-        <p:nvSpPr>
-          <p:cNvPr id="6" name="Text 4"/>
-          <p:cNvSpPr/>
-          <p:nvPr/>
-        </p:nvSpPr>
-        <p:spPr>
-          <a:xfrm>
-            <a:off x="3931920" y="3383280"/>
-            <a:ext cx="3200400" cy="640080"/>
-          </a:xfrm>
-          <a:prstGeom prst="rect">
-            <a:avLst/>
-          </a:prstGeom>
-          <a:solidFill>
-            <a:srgbClr val="BFDFFF"/>
-          </a:solidFill>
-          <a:ln/>
-        </p:spPr>
-        <p:txBody>
-          <a:bodyPr wrap="square" rtlCol="0" anchor="ctr"/>
-          <a:lstStyle/>
-          <a:p>
-            <a:pPr algn="ctr" indent="0" marL="0">
-              <a:buNone/>
-            </a:pPr>
-            <a:r>
-              <a:rPr lang="en-US" sz="1200" b="1" dirty="0">
-                <a:solidFill>
-                  <a:srgbClr val="000000"/>
-                </a:solidFill>
-              </a:rPr>
-              <a:t>Отдел инфраструктурных решений</a:t>
-            </a:r>
-            <a:endParaRPr lang="en-US" sz="1200" dirty="0"/>
-          </a:p>
-          <a:p>
-            <a:pPr algn="ctr" indent="0" marL="0">
-              <a:buNone/>
-            </a:pPr>
-            <a:r>
-              <a:rPr lang="en-US" sz="1200" b="1" dirty="0">
-                <a:solidFill>
-                  <a:srgbClr val="000000"/>
-                </a:solidFill>
-              </a:rPr>
-              <a:t>Руководитель: Быковский Роман Вадимович</a:t>
-            </a:r>
-            <a:endParaRPr lang="en-US" sz="1200" dirty="0"/>
-          </a:p>
-        </p:txBody>
-      </p:sp>
-      <p:sp>
-        <p:nvSpPr>
-          <p:cNvPr id="7" name="Text 5"/>
-          <p:cNvSpPr/>
-          <p:nvPr/>
-        </p:nvSpPr>
-        <p:spPr>
-          <a:xfrm>
-            <a:off x="7406640" y="4206240"/>
-            <a:ext cx="3200400" cy="640080"/>
-          </a:xfrm>
-          <a:prstGeom prst="rect">
-            <a:avLst/>
-          </a:prstGeom>
-          <a:solidFill>
-            <a:srgbClr val="BFDFFF"/>
-          </a:solidFill>
-          <a:ln/>
-        </p:spPr>
-        <p:txBody>
-          <a:bodyPr wrap="square" rtlCol="0" anchor="ctr"/>
-          <a:lstStyle/>
-          <a:p>
-            <a:pPr algn="ctr" indent="0" marL="0">
-              <a:buNone/>
-            </a:pPr>
-            <a:r>
-              <a:rPr lang="en-US" sz="1200" b="1" dirty="0">
-                <a:solidFill>
-                  <a:srgbClr val="000000"/>
-                </a:solidFill>
-              </a:rPr>
-              <a:t>Группа технической поддержки</a:t>
-            </a:r>
-            <a:endParaRPr lang="en-US" sz="1200" dirty="0"/>
-          </a:p>
-          <a:p>
-            <a:pPr algn="ctr" indent="0" marL="0">
-              <a:buNone/>
-            </a:pPr>
-            <a:r>
-              <a:rPr lang="en-US" sz="1200" b="1" dirty="0">
-                <a:solidFill>
-                  <a:srgbClr val="000000"/>
-                </a:solidFill>
-              </a:rPr>
-              <a:t>Руководитель: Ануфриев Игорь Николаевич</a:t>
-            </a:r>
-            <a:endParaRPr lang="en-US" sz="1200" dirty="0"/>
-          </a:p>
-        </p:txBody>
-      </p:sp>
-      <p:sp>
-        <p:nvSpPr>
-          <p:cNvPr id="8" name="Text 6"/>
-          <p:cNvSpPr/>
-          <p:nvPr/>
-        </p:nvSpPr>
-        <p:spPr>
-          <a:xfrm>
-            <a:off x="3931920" y="5029200"/>
-            <a:ext cx="3200400" cy="640080"/>
-          </a:xfrm>
-          <a:prstGeom prst="rect">
-            <a:avLst/>
-          </a:prstGeom>
-          <a:solidFill>
-            <a:srgbClr val="BFDFFF"/>
-          </a:solidFill>
-          <a:ln/>
-        </p:spPr>
-        <p:txBody>
-          <a:bodyPr wrap="square" rtlCol="0" anchor="ctr"/>
-          <a:lstStyle/>
-          <a:p>
-            <a:pPr algn="ctr" indent="0" marL="0">
-              <a:buNone/>
-            </a:pPr>
-            <a:r>
-              <a:rPr lang="en-US" sz="1200" b="1" dirty="0">
-                <a:solidFill>
-                  <a:srgbClr val="000000"/>
-                </a:solidFill>
-              </a:rPr>
-              <a:t>Отдел программирования</a:t>
-            </a:r>
-            <a:endParaRPr lang="en-US" sz="1200" dirty="0"/>
-          </a:p>
-          <a:p>
-            <a:pPr algn="ctr" indent="0" marL="0">
-              <a:buNone/>
-            </a:pPr>
-            <a:r>
-              <a:rPr lang="en-US" sz="1200" b="1" dirty="0">
-                <a:solidFill>
-                  <a:srgbClr val="000000"/>
-                </a:solidFill>
-              </a:rPr>
-              <a:t>Руководитель: —</a:t>
-            </a:r>
-            <a:endParaRPr lang="en-US" sz="1200" dirty="0"/>
-          </a:p>
-        </p:txBody>
-      </p:sp>
-      <p:sp>
-        <p:nvSpPr>
-          <p:cNvPr id="9" name="Text 7"/>
-          <p:cNvSpPr/>
-          <p:nvPr/>
-        </p:nvSpPr>
-        <p:spPr>
-          <a:xfrm>
-            <a:off x="3931920" y="5852160"/>
-            <a:ext cx="3200400" cy="640080"/>
-          </a:xfrm>
-          <a:prstGeom prst="rect">
-            <a:avLst/>
-          </a:prstGeom>
-          <a:solidFill>
-            <a:srgbClr val="BFDFFF"/>
-          </a:solidFill>
-          <a:ln/>
-        </p:spPr>
-        <p:txBody>
-          <a:bodyPr wrap="square" rtlCol="0" anchor="ctr"/>
-          <a:lstStyle/>
-          <a:p>
-            <a:pPr algn="ctr" indent="0" marL="0">
-              <a:buNone/>
-            </a:pPr>
-            <a:r>
-              <a:rPr lang="en-US" sz="1200" b="1" dirty="0">
-                <a:solidFill>
-                  <a:srgbClr val="000000"/>
-                </a:solidFill>
-              </a:rPr>
-              <a:t>Отдел развития цифровых платформ</a:t>
-            </a:r>
-            <a:endParaRPr lang="en-US" sz="1200" dirty="0"/>
-          </a:p>
-          <a:p>
-            <a:pPr algn="ctr" indent="0" marL="0">
-              <a:buNone/>
-            </a:pPr>
-            <a:r>
-              <a:rPr lang="en-US" sz="1200" b="1" dirty="0">
-                <a:solidFill>
-                  <a:srgbClr val="000000"/>
-                </a:solidFill>
-              </a:rPr>
-              <a:t>Руководитель: Рубан Федор Олегович</a:t>
-            </a:r>
-            <a:endParaRPr lang="en-US" sz="1200" dirty="0"/>
-          </a:p>
-        </p:txBody>
-      </p:sp>
-      <p:sp>
-        <p:nvSpPr>
-          <p:cNvPr id="10" name="Text 8"/>
-          <p:cNvSpPr/>
-          <p:nvPr/>
-        </p:nvSpPr>
-        <p:spPr>
-          <a:xfrm>
-            <a:off x="3931920" y="6675120"/>
-            <a:ext cx="3200400" cy="640080"/>
-          </a:xfrm>
-          <a:prstGeom prst="rect">
-            <a:avLst/>
-          </a:prstGeom>
-          <a:solidFill>
-            <a:srgbClr val="BFDFFF"/>
-          </a:solidFill>
-          <a:ln/>
-        </p:spPr>
-        <p:txBody>
-          <a:bodyPr wrap="square" rtlCol="0" anchor="ctr"/>
-          <a:lstStyle/>
-          <a:p>
-            <a:pPr algn="ctr" indent="0" marL="0">
-              <a:buNone/>
-            </a:pPr>
-            <a:r>
-              <a:rPr lang="en-US" sz="1200" b="1" dirty="0">
-                <a:solidFill>
-                  <a:srgbClr val="000000"/>
-                </a:solidFill>
-              </a:rPr>
-              <a:t>Отдел разработки веб-решений</a:t>
-            </a:r>
-            <a:endParaRPr lang="en-US" sz="1200" dirty="0"/>
-          </a:p>
-          <a:p>
-            <a:pPr algn="ctr" indent="0" marL="0">
-              <a:buNone/>
-            </a:pPr>
-            <a:r>
-              <a:rPr lang="en-US" sz="1200" b="1" dirty="0">
-                <a:solidFill>
-                  <a:srgbClr val="000000"/>
-                </a:solidFill>
-              </a:rPr>
-              <a:t>Руководитель: Горев Андрей Юрьевич</a:t>
-            </a:r>
-            <a:endParaRPr lang="en-US" sz="1200" dirty="0"/>
-          </a:p>
-        </p:txBody>
-      </p:sp>
-      <p:sp>
-        <p:nvSpPr>
-          <p:cNvPr id="11" name="Text 9"/>
-          <p:cNvSpPr/>
-          <p:nvPr/>
-        </p:nvSpPr>
-        <p:spPr>
-          <a:xfrm>
-            <a:off x="457200" y="7498080"/>
-            <a:ext cx="3200400" cy="640080"/>
-          </a:xfrm>
-          <a:prstGeom prst="rect">
-            <a:avLst/>
-          </a:prstGeom>
-          <a:solidFill>
-            <a:srgbClr val="BFDFFF"/>
-          </a:solidFill>
-          <a:ln/>
-        </p:spPr>
-        <p:txBody>
-          <a:bodyPr wrap="square" rtlCol="0" anchor="ctr"/>
-          <a:lstStyle/>
-          <a:p>
-            <a:pPr algn="ctr" indent="0" marL="0">
-              <a:buNone/>
-            </a:pPr>
-            <a:r>
-              <a:rPr lang="en-US" sz="1200" b="1" dirty="0">
-                <a:solidFill>
-                  <a:srgbClr val="000000"/>
-                </a:solidFill>
-              </a:rPr>
-              <a:t>Отдел аналитики</a:t>
-            </a:r>
-            <a:endParaRPr lang="en-US" sz="1200" dirty="0"/>
-          </a:p>
-          <a:p>
-            <a:pPr algn="ctr" indent="0" marL="0">
-              <a:buNone/>
-            </a:pPr>
-            <a:r>
-              <a:rPr lang="en-US" sz="1200" b="1" dirty="0">
-                <a:solidFill>
-                  <a:srgbClr val="000000"/>
-                </a:solidFill>
-              </a:rPr>
-              <a:t>Руководитель: Шапошников Алексей Викторович</a:t>
-            </a:r>
-            <a:endParaRPr lang="en-US" sz="1200" dirty="0"/>
-          </a:p>
-        </p:txBody>
-      </p:sp>
-      <p:sp>
-        <p:nvSpPr>
-          <p:cNvPr id="12" name="Text 10"/>
-          <p:cNvSpPr/>
-          <p:nvPr/>
-        </p:nvSpPr>
-        <p:spPr>
-          <a:xfrm>
-            <a:off x="457200" y="8321040"/>
-            <a:ext cx="3200400" cy="640080"/>
-          </a:xfrm>
-          <a:prstGeom prst="rect">
-            <a:avLst/>
-          </a:prstGeom>
-          <a:solidFill>
-            <a:srgbClr val="BFDFFF"/>
-          </a:solidFill>
-          <a:ln/>
-        </p:spPr>
-        <p:txBody>
-          <a:bodyPr wrap="square" rtlCol="0" anchor="ctr"/>
-          <a:lstStyle/>
-          <a:p>
-            <a:pPr algn="ctr" indent="0" marL="0">
-              <a:buNone/>
-            </a:pPr>
-            <a:r>
-              <a:rPr lang="en-US" sz="1200" b="1" dirty="0">
-                <a:solidFill>
-                  <a:srgbClr val="000000"/>
-                </a:solidFill>
-              </a:rPr>
-              <a:t>Отдел информационных технологий в г. Москве</a:t>
-            </a:r>
-            <a:endParaRPr lang="en-US" sz="1200" dirty="0"/>
-          </a:p>
-          <a:p>
-            <a:pPr algn="ctr" indent="0" marL="0">
-              <a:buNone/>
-            </a:pPr>
-            <a:r>
-              <a:rPr lang="en-US" sz="1200" b="1" dirty="0">
-                <a:solidFill>
-                  <a:srgbClr val="000000"/>
-                </a:solidFill>
-              </a:rPr>
-              <a:t>Руководитель: Толкаев Евгений Юрьевич</a:t>
-            </a:r>
-            <a:endParaRPr lang="en-US" sz="1200" dirty="0"/>
-          </a:p>
-        </p:txBody>
-      </p:sp>
-      <p:sp>
-        <p:nvSpPr>
-          <p:cNvPr id="13" name="Text 11"/>
-          <p:cNvSpPr/>
-          <p:nvPr/>
-        </p:nvSpPr>
-        <p:spPr>
-          <a:xfrm>
-            <a:off x="457200" y="9144000"/>
-            <a:ext cx="3200400" cy="640080"/>
-          </a:xfrm>
-          <a:prstGeom prst="rect">
-            <a:avLst/>
-          </a:prstGeom>
-          <a:solidFill>
-            <a:srgbClr val="BFDFFF"/>
-          </a:solidFill>
-          <a:ln/>
-        </p:spPr>
-        <p:txBody>
-          <a:bodyPr wrap="square" rtlCol="0" anchor="ctr"/>
-          <a:lstStyle/>
-          <a:p>
-            <a:pPr algn="ctr" indent="0" marL="0">
-              <a:buNone/>
-            </a:pPr>
-            <a:r>
-              <a:rPr lang="en-US" sz="1200" b="1" dirty="0">
-                <a:solidFill>
-                  <a:srgbClr val="000000"/>
-                </a:solidFill>
-              </a:rPr>
-              <a:t>Отдел инфраструктурных решений</a:t>
-            </a:r>
-            <a:endParaRPr lang="en-US" sz="1200" dirty="0"/>
-          </a:p>
-          <a:p>
-            <a:pPr algn="ctr" indent="0" marL="0">
-              <a:buNone/>
-            </a:pPr>
-            <a:r>
-              <a:rPr lang="en-US" sz="1200" b="1" dirty="0">
-                <a:solidFill>
-                  <a:srgbClr val="000000"/>
-                </a:solidFill>
-              </a:rPr>
-              <a:t>Руководитель: Быковский Роман Вадимович</a:t>
-            </a:r>
-            <a:endParaRPr lang="en-US" sz="1200" dirty="0"/>
-          </a:p>
-        </p:txBody>
-      </p:sp>
-      <p:sp>
-        <p:nvSpPr>
-          <p:cNvPr id="14" name="Text 12"/>
-          <p:cNvSpPr/>
-          <p:nvPr/>
-        </p:nvSpPr>
-        <p:spPr>
-          <a:xfrm>
-            <a:off x="3931920" y="9966960"/>
-            <a:ext cx="3200400" cy="640080"/>
-          </a:xfrm>
-          <a:prstGeom prst="rect">
-            <a:avLst/>
-          </a:prstGeom>
-          <a:solidFill>
-            <a:srgbClr val="BFDFFF"/>
-          </a:solidFill>
-          <a:ln/>
-        </p:spPr>
-        <p:txBody>
-          <a:bodyPr wrap="square" rtlCol="0" anchor="ctr"/>
-          <a:lstStyle/>
-          <a:p>
-            <a:pPr algn="ctr" indent="0" marL="0">
-              <a:buNone/>
-            </a:pPr>
-            <a:r>
-              <a:rPr lang="en-US" sz="1200" b="1" dirty="0">
-                <a:solidFill>
-                  <a:srgbClr val="000000"/>
-                </a:solidFill>
-              </a:rPr>
-              <a:t>Группа технической поддержки</a:t>
-            </a:r>
-            <a:endParaRPr lang="en-US" sz="1200" dirty="0"/>
-          </a:p>
-          <a:p>
-            <a:pPr algn="ctr" indent="0" marL="0">
-              <a:buNone/>
-            </a:pPr>
-            <a:r>
-              <a:rPr lang="en-US" sz="1200" b="1" dirty="0">
-                <a:solidFill>
-                  <a:srgbClr val="000000"/>
-                </a:solidFill>
-              </a:rPr>
-              <a:t>Руководитель: Ануфриев Игорь Николаевич</a:t>
-            </a:r>
-            <a:endParaRPr lang="en-US" sz="1200" dirty="0"/>
-          </a:p>
-        </p:txBody>
-      </p:sp>
-      <p:sp>
-        <p:nvSpPr>
-          <p:cNvPr id="15" name="Text 13"/>
-          <p:cNvSpPr/>
-          <p:nvPr/>
-        </p:nvSpPr>
-        <p:spPr>
-          <a:xfrm>
-            <a:off x="457200" y="10789920"/>
-            <a:ext cx="3200400" cy="640080"/>
-          </a:xfrm>
-          <a:prstGeom prst="rect">
-            <a:avLst/>
-          </a:prstGeom>
-          <a:solidFill>
-            <a:srgbClr val="BFDFFF"/>
-          </a:solidFill>
-          <a:ln/>
-        </p:spPr>
-        <p:txBody>
-          <a:bodyPr wrap="square" rtlCol="0" anchor="ctr"/>
-          <a:lstStyle/>
-          <a:p>
-            <a:pPr algn="ctr" indent="0" marL="0">
-              <a:buNone/>
-            </a:pPr>
-            <a:r>
-              <a:rPr lang="en-US" sz="1200" b="1" dirty="0">
-                <a:solidFill>
-                  <a:srgbClr val="000000"/>
-                </a:solidFill>
-              </a:rPr>
-              <a:t>Группа технической поддержки</a:t>
-            </a:r>
-            <a:endParaRPr lang="en-US" sz="1200" dirty="0"/>
-          </a:p>
-          <a:p>
-            <a:pPr algn="ctr" indent="0" marL="0">
-              <a:buNone/>
-            </a:pPr>
-            <a:r>
-              <a:rPr lang="en-US" sz="1200" b="1" dirty="0">
-                <a:solidFill>
-                  <a:srgbClr val="000000"/>
-                </a:solidFill>
-              </a:rPr>
-              <a:t>Руководитель: Ануфриев Игорь Николаевич</a:t>
-            </a:r>
-            <a:endParaRPr lang="en-US" sz="1200" dirty="0"/>
-          </a:p>
-        </p:txBody>
-      </p:sp>
-      <p:sp>
-        <p:nvSpPr>
-          <p:cNvPr id="16" name="Text 14"/>
-          <p:cNvSpPr/>
-          <p:nvPr/>
-        </p:nvSpPr>
-        <p:spPr>
-          <a:xfrm>
-            <a:off x="457200" y="11612880"/>
-            <a:ext cx="3200400" cy="640080"/>
-          </a:xfrm>
-          <a:prstGeom prst="rect">
-            <a:avLst/>
-          </a:prstGeom>
-          <a:solidFill>
-            <a:srgbClr val="BFDFFF"/>
-          </a:solidFill>
-          <a:ln/>
-        </p:spPr>
-        <p:txBody>
-          <a:bodyPr wrap="square" rtlCol="0" anchor="ctr"/>
-          <a:lstStyle/>
-          <a:p>
-            <a:pPr algn="ctr" indent="0" marL="0">
-              <a:buNone/>
-            </a:pPr>
-            <a:r>
-              <a:rPr lang="en-US" sz="1200" b="1" dirty="0">
-                <a:solidFill>
-                  <a:srgbClr val="000000"/>
-                </a:solidFill>
-              </a:rPr>
-              <a:t>Отдел программирования</a:t>
-            </a:r>
-            <a:endParaRPr lang="en-US" sz="1200" dirty="0"/>
-          </a:p>
-          <a:p>
-            <a:pPr algn="ctr" indent="0" marL="0">
-              <a:buNone/>
-            </a:pPr>
-            <a:r>
-              <a:rPr lang="en-US" sz="1200" b="1" dirty="0">
-                <a:solidFill>
-                  <a:srgbClr val="000000"/>
-                </a:solidFill>
-              </a:rPr>
-              <a:t>Руководитель: —</a:t>
-            </a:r>
-            <a:endParaRPr lang="en-US" sz="1200" dirty="0"/>
-          </a:p>
-        </p:txBody>
-      </p:sp>
-      <p:sp>
-        <p:nvSpPr>
-          <p:cNvPr id="17" name="Text 15"/>
-          <p:cNvSpPr/>
-          <p:nvPr/>
-        </p:nvSpPr>
-        <p:spPr>
-          <a:xfrm>
-            <a:off x="457200" y="12435840"/>
-            <a:ext cx="3200400" cy="640080"/>
-          </a:xfrm>
-          <a:prstGeom prst="rect">
-            <a:avLst/>
-          </a:prstGeom>
-          <a:solidFill>
-            <a:srgbClr val="BFDFFF"/>
-          </a:solidFill>
-          <a:ln/>
-        </p:spPr>
-        <p:txBody>
-          <a:bodyPr wrap="square" rtlCol="0" anchor="ctr"/>
-          <a:lstStyle/>
-          <a:p>
-            <a:pPr algn="ctr" indent="0" marL="0">
-              <a:buNone/>
-            </a:pPr>
-            <a:r>
-              <a:rPr lang="en-US" sz="1200" b="1" dirty="0">
-                <a:solidFill>
-                  <a:srgbClr val="000000"/>
-                </a:solidFill>
-              </a:rPr>
-              <a:t>Отдел развития цифровых платформ</a:t>
-            </a:r>
-            <a:endParaRPr lang="en-US" sz="1200" dirty="0"/>
-          </a:p>
-          <a:p>
-            <a:pPr algn="ctr" indent="0" marL="0">
-              <a:buNone/>
-            </a:pPr>
-            <a:r>
-              <a:rPr lang="en-US" sz="1200" b="1" dirty="0">
-                <a:solidFill>
-                  <a:srgbClr val="000000"/>
-                </a:solidFill>
-              </a:rPr>
-              <a:t>Руководитель: Рубан Федор Олегович</a:t>
-            </a:r>
-            <a:endParaRPr lang="en-US" sz="1200" dirty="0"/>
-          </a:p>
-        </p:txBody>
-      </p:sp>
-      <p:sp>
-        <p:nvSpPr>
-          <p:cNvPr id="18" name="Text 16"/>
-          <p:cNvSpPr/>
-          <p:nvPr/>
-        </p:nvSpPr>
-        <p:spPr>
-          <a:xfrm>
-            <a:off x="457200" y="13258800"/>
-            <a:ext cx="3200400" cy="640080"/>
-          </a:xfrm>
-          <a:prstGeom prst="rect">
-            <a:avLst/>
-          </a:prstGeom>
-          <a:solidFill>
-            <a:srgbClr val="BFDFFF"/>
-          </a:solidFill>
-          <a:ln/>
-        </p:spPr>
-        <p:txBody>
-          <a:bodyPr wrap="square" rtlCol="0" anchor="ctr"/>
-          <a:lstStyle/>
-          <a:p>
-            <a:pPr algn="ctr" indent="0" marL="0">
-              <a:buNone/>
-            </a:pPr>
-            <a:r>
-              <a:rPr lang="en-US" sz="1200" b="1" dirty="0">
-                <a:solidFill>
-                  <a:srgbClr val="000000"/>
-                </a:solidFill>
-              </a:rPr>
-              <a:t>Отдел разработки веб-решений</a:t>
-            </a:r>
-            <a:endParaRPr lang="en-US" sz="1200" dirty="0"/>
-          </a:p>
-          <a:p>
-            <a:pPr algn="ctr" indent="0" marL="0">
-              <a:buNone/>
-            </a:pPr>
-            <a:r>
-              <a:rPr lang="en-US" sz="1200" b="1" dirty="0">
-                <a:solidFill>
-                  <a:srgbClr val="000000"/>
-                </a:solidFill>
-              </a:rPr>
-              <a:t>Руководитель: Горев Андрей Юрьевич</a:t>
+              <a:t>Руководитель: Соколова Эльвира Сергеевна</a:t>
             </a:r>
             <a:endParaRPr lang="en-US" sz="1200" dirty="0"/>
           </a:p>

</xml_diff>